<commit_message>
khobar.html: remove No Show column from template
Strip the NO SHOW column shapes from branch and continuation slides
in AlKhobar_Single_Template.pptx so the Al Khobar report has no
No Show field.
</commit_message>
<xml_diff>
--- a/template/AlKhobar_Single_Template.pptx
+++ b/template/AlKhobar_Single_Template.pptx
@@ -5813,357 +5813,6 @@
           </a:p>
         </p:txBody>
       </p:sp>
-      <p:sp>
-        <p:nvSpPr>
-          <p:cNvPr id="28" name="Text 25"/>
-          <p:cNvSpPr/>
-          <p:nvPr/>
-        </p:nvSpPr>
-        <p:spPr>
-          <a:xfrm>
-            <a:off x="6172200" y="2450592"/>
-            <a:ext cx="960120" cy="201168"/>
-          </a:xfrm>
-          <a:prstGeom prst="rect">
-            <a:avLst/>
-          </a:prstGeom>
-          <a:noFill/>
-          <a:ln/>
-        </p:spPr>
-        <p:txBody>
-          <a:bodyPr wrap="square" lIns="0" tIns="0" rIns="0" bIns="0" rtlCol="0" anchor="ctr"/>
-          <a:lstStyle/>
-          <a:p>
-            <a:pPr algn="ctr" indent="0" marL="0">
-              <a:buNone/>
-            </a:pPr>
-            <a:r>
-              <a:rPr lang="en-US" sz="800" b="1" spc="100" kern="0" dirty="0">
-                <a:solidFill>
-                  <a:srgbClr val="FFFFFF"/>
-                </a:solidFill>
-                <a:latin typeface="Plus Jakarta Sans" pitchFamily="34" charset="0"/>
-                <a:ea typeface="Plus Jakarta Sans" pitchFamily="34" charset="-122"/>
-                <a:cs typeface="Plus Jakarta Sans" pitchFamily="34" charset="-120"/>
-              </a:rPr>
-              <a:t>NO SHOW</a:t>
-            </a:r>
-            <a:endParaRPr lang="en-US" sz="800" dirty="0"/>
-          </a:p>
-        </p:txBody>
-      </p:sp>
-      <p:sp>
-        <p:nvSpPr>
-          <p:cNvPr id="34" name="Text 31"/>
-          <p:cNvSpPr/>
-          <p:nvPr/>
-        </p:nvSpPr>
-        <p:spPr>
-          <a:xfrm>
-            <a:off x="6172200" y="2871216"/>
-            <a:ext cx="960120" cy="201168"/>
-          </a:xfrm>
-          <a:prstGeom prst="rect">
-            <a:avLst/>
-          </a:prstGeom>
-          <a:noFill/>
-          <a:ln/>
-        </p:spPr>
-        <p:txBody>
-          <a:bodyPr wrap="square" lIns="0" tIns="0" rIns="0" bIns="0" rtlCol="0" anchor="ctr"/>
-          <a:lstStyle/>
-          <a:p>
-            <a:pPr algn="ctr" indent="0" marL="0">
-              <a:buNone/>
-            </a:pPr>
-            <a:r>
-              <a:rPr lang="en-US" sz="1000" dirty="0">
-                <a:solidFill>
-                  <a:srgbClr val="5A5470"/>
-                </a:solidFill>
-                <a:latin typeface="Times New Roman" pitchFamily="34" charset="0"/>
-                <a:ea typeface="Times New Roman" pitchFamily="34" charset="-122"/>
-                <a:cs typeface="Times New Roman" pitchFamily="34" charset="-120"/>
-              </a:rPr>
-              <a:t>—</a:t>
-            </a:r>
-            <a:endParaRPr lang="en-US" sz="1000" dirty="0"/>
-          </a:p>
-        </p:txBody>
-      </p:sp>
-      <p:sp>
-        <p:nvSpPr>
-          <p:cNvPr id="39" name="Text 36"/>
-          <p:cNvSpPr/>
-          <p:nvPr/>
-        </p:nvSpPr>
-        <p:spPr>
-          <a:xfrm>
-            <a:off x="6172200" y="3072384"/>
-            <a:ext cx="960120" cy="201168"/>
-          </a:xfrm>
-          <a:prstGeom prst="rect">
-            <a:avLst/>
-          </a:prstGeom>
-          <a:noFill/>
-          <a:ln/>
-        </p:spPr>
-        <p:txBody>
-          <a:bodyPr wrap="square" lIns="0" tIns="0" rIns="0" bIns="0" rtlCol="0" anchor="ctr"/>
-          <a:lstStyle/>
-          <a:p>
-            <a:pPr algn="ctr" indent="0" marL="0">
-              <a:buNone/>
-            </a:pPr>
-            <a:r>
-              <a:rPr lang="en-US" sz="1000" dirty="0">
-                <a:solidFill>
-                  <a:srgbClr val="5A5470"/>
-                </a:solidFill>
-                <a:latin typeface="Times New Roman" pitchFamily="34" charset="0"/>
-                <a:ea typeface="Times New Roman" pitchFamily="34" charset="-122"/>
-                <a:cs typeface="Times New Roman" pitchFamily="34" charset="-120"/>
-              </a:rPr>
-              <a:t>—</a:t>
-            </a:r>
-            <a:endParaRPr lang="en-US" sz="1000" dirty="0"/>
-          </a:p>
-        </p:txBody>
-      </p:sp>
-      <p:sp>
-        <p:nvSpPr>
-          <p:cNvPr id="43" name="Text 40"/>
-          <p:cNvSpPr/>
-          <p:nvPr/>
-        </p:nvSpPr>
-        <p:spPr>
-          <a:xfrm>
-            <a:off x="6172200" y="3273552"/>
-            <a:ext cx="960120" cy="201168"/>
-          </a:xfrm>
-          <a:prstGeom prst="rect">
-            <a:avLst/>
-          </a:prstGeom>
-          <a:noFill/>
-          <a:ln/>
-        </p:spPr>
-        <p:txBody>
-          <a:bodyPr wrap="square" lIns="0" tIns="0" rIns="0" bIns="0" rtlCol="0" anchor="ctr"/>
-          <a:lstStyle/>
-          <a:p>
-            <a:pPr algn="ctr" indent="0" marL="0">
-              <a:buNone/>
-            </a:pPr>
-            <a:r>
-              <a:rPr lang="en-US" sz="1000" dirty="0">
-                <a:solidFill>
-                  <a:srgbClr val="5A5470"/>
-                </a:solidFill>
-                <a:latin typeface="Times New Roman" pitchFamily="34" charset="0"/>
-                <a:ea typeface="Times New Roman" pitchFamily="34" charset="-122"/>
-                <a:cs typeface="Times New Roman" pitchFamily="34" charset="-120"/>
-              </a:rPr>
-              <a:t>—</a:t>
-            </a:r>
-            <a:endParaRPr lang="en-US" sz="1000" dirty="0"/>
-          </a:p>
-        </p:txBody>
-      </p:sp>
-      <p:sp>
-        <p:nvSpPr>
-          <p:cNvPr id="48" name="Text 45"/>
-          <p:cNvSpPr/>
-          <p:nvPr/>
-        </p:nvSpPr>
-        <p:spPr>
-          <a:xfrm>
-            <a:off x="6172200" y="3474720"/>
-            <a:ext cx="960120" cy="201168"/>
-          </a:xfrm>
-          <a:prstGeom prst="rect">
-            <a:avLst/>
-          </a:prstGeom>
-          <a:noFill/>
-          <a:ln/>
-        </p:spPr>
-        <p:txBody>
-          <a:bodyPr wrap="square" lIns="0" tIns="0" rIns="0" bIns="0" rtlCol="0" anchor="ctr"/>
-          <a:lstStyle/>
-          <a:p>
-            <a:pPr algn="ctr" indent="0" marL="0">
-              <a:buNone/>
-            </a:pPr>
-            <a:r>
-              <a:rPr lang="en-US" sz="1000" dirty="0">
-                <a:solidFill>
-                  <a:srgbClr val="5A5470"/>
-                </a:solidFill>
-                <a:latin typeface="Times New Roman" pitchFamily="34" charset="0"/>
-                <a:ea typeface="Times New Roman" pitchFamily="34" charset="-122"/>
-                <a:cs typeface="Times New Roman" pitchFamily="34" charset="-120"/>
-              </a:rPr>
-              <a:t>—</a:t>
-            </a:r>
-            <a:endParaRPr lang="en-US" sz="1000" dirty="0"/>
-          </a:p>
-        </p:txBody>
-      </p:sp>
-      <p:sp>
-        <p:nvSpPr>
-          <p:cNvPr id="55" name="Text 52"/>
-          <p:cNvSpPr/>
-          <p:nvPr/>
-        </p:nvSpPr>
-        <p:spPr>
-          <a:xfrm>
-            <a:off x="6172200" y="3877056"/>
-            <a:ext cx="960120" cy="201168"/>
-          </a:xfrm>
-          <a:prstGeom prst="rect">
-            <a:avLst/>
-          </a:prstGeom>
-          <a:noFill/>
-          <a:ln/>
-        </p:spPr>
-        <p:txBody>
-          <a:bodyPr wrap="square" lIns="0" tIns="0" rIns="0" bIns="0" rtlCol="0" anchor="ctr"/>
-          <a:lstStyle/>
-          <a:p>
-            <a:pPr algn="ctr" indent="0" marL="0">
-              <a:buNone/>
-            </a:pPr>
-            <a:r>
-              <a:rPr lang="en-US" sz="1000" dirty="0">
-                <a:solidFill>
-                  <a:srgbClr val="5A5470"/>
-                </a:solidFill>
-                <a:latin typeface="Times New Roman" pitchFamily="34" charset="0"/>
-                <a:ea typeface="Times New Roman" pitchFamily="34" charset="-122"/>
-                <a:cs typeface="Times New Roman" pitchFamily="34" charset="-120"/>
-              </a:rPr>
-              <a:t>—</a:t>
-            </a:r>
-            <a:endParaRPr lang="en-US" sz="1000" dirty="0"/>
-          </a:p>
-        </p:txBody>
-      </p:sp>
-      <p:sp>
-        <p:nvSpPr>
-          <p:cNvPr id="60" name="Text 57"/>
-          <p:cNvSpPr/>
-          <p:nvPr/>
-        </p:nvSpPr>
-        <p:spPr>
-          <a:xfrm>
-            <a:off x="6172200" y="4078224"/>
-            <a:ext cx="960120" cy="201168"/>
-          </a:xfrm>
-          <a:prstGeom prst="rect">
-            <a:avLst/>
-          </a:prstGeom>
-          <a:noFill/>
-          <a:ln/>
-        </p:spPr>
-        <p:txBody>
-          <a:bodyPr wrap="square" lIns="0" tIns="0" rIns="0" bIns="0" rtlCol="0" anchor="ctr"/>
-          <a:lstStyle/>
-          <a:p>
-            <a:pPr algn="ctr" indent="0" marL="0">
-              <a:buNone/>
-            </a:pPr>
-            <a:r>
-              <a:rPr lang="en-US" sz="1000" dirty="0">
-                <a:solidFill>
-                  <a:srgbClr val="5A5470"/>
-                </a:solidFill>
-                <a:latin typeface="Times New Roman" pitchFamily="34" charset="0"/>
-                <a:ea typeface="Times New Roman" pitchFamily="34" charset="-122"/>
-                <a:cs typeface="Times New Roman" pitchFamily="34" charset="-120"/>
-              </a:rPr>
-              <a:t>—</a:t>
-            </a:r>
-            <a:endParaRPr lang="en-US" sz="1000" dirty="0"/>
-          </a:p>
-        </p:txBody>
-      </p:sp>
-      <p:sp>
-        <p:nvSpPr>
-          <p:cNvPr id="64" name="Text 61"/>
-          <p:cNvSpPr/>
-          <p:nvPr/>
-        </p:nvSpPr>
-        <p:spPr>
-          <a:xfrm>
-            <a:off x="6172200" y="4279392"/>
-            <a:ext cx="960120" cy="201168"/>
-          </a:xfrm>
-          <a:prstGeom prst="rect">
-            <a:avLst/>
-          </a:prstGeom>
-          <a:noFill/>
-          <a:ln/>
-        </p:spPr>
-        <p:txBody>
-          <a:bodyPr wrap="square" lIns="0" tIns="0" rIns="0" bIns="0" rtlCol="0" anchor="ctr"/>
-          <a:lstStyle/>
-          <a:p>
-            <a:pPr algn="ctr" indent="0" marL="0">
-              <a:buNone/>
-            </a:pPr>
-            <a:r>
-              <a:rPr lang="en-US" sz="1000" dirty="0">
-                <a:solidFill>
-                  <a:srgbClr val="5A5470"/>
-                </a:solidFill>
-                <a:latin typeface="Times New Roman" pitchFamily="34" charset="0"/>
-                <a:ea typeface="Times New Roman" pitchFamily="34" charset="-122"/>
-                <a:cs typeface="Times New Roman" pitchFamily="34" charset="-120"/>
-              </a:rPr>
-              <a:t>—</a:t>
-            </a:r>
-            <a:endParaRPr lang="en-US" sz="1000" dirty="0"/>
-          </a:p>
-        </p:txBody>
-      </p:sp>
-      <p:sp>
-        <p:nvSpPr>
-          <p:cNvPr id="69" name="Text 66"/>
-          <p:cNvSpPr/>
-          <p:nvPr/>
-        </p:nvSpPr>
-        <p:spPr>
-          <a:xfrm>
-            <a:off x="6172200" y="4480560"/>
-            <a:ext cx="960120" cy="201168"/>
-          </a:xfrm>
-          <a:prstGeom prst="rect">
-            <a:avLst/>
-          </a:prstGeom>
-          <a:noFill/>
-          <a:ln/>
-        </p:spPr>
-        <p:txBody>
-          <a:bodyPr wrap="square" lIns="0" tIns="0" rIns="0" bIns="0" rtlCol="0" anchor="ctr"/>
-          <a:lstStyle/>
-          <a:p>
-            <a:pPr algn="ctr" indent="0" marL="0">
-              <a:buNone/>
-            </a:pPr>
-            <a:r>
-              <a:rPr lang="en-US" sz="1000" dirty="0">
-                <a:solidFill>
-                  <a:srgbClr val="5A5470"/>
-                </a:solidFill>
-                <a:latin typeface="Times New Roman" pitchFamily="34" charset="0"/>
-                <a:ea typeface="Times New Roman" pitchFamily="34" charset="-122"/>
-                <a:cs typeface="Times New Roman" pitchFamily="34" charset="-120"/>
-              </a:rPr>
-              <a:t>—</a:t>
-            </a:r>
-            <a:endParaRPr lang="en-US" sz="1000" dirty="0"/>
-          </a:p>
-        </p:txBody>
-      </p:sp>
     </p:spTree>
   </p:cSld>
   <p:clrMapOvr>
@@ -8968,591 +8617,6 @@
               <a:t>CONFIDENTIAL · Page 3</a:t>
             </a:r>
             <a:endParaRPr lang="en-US" sz="700" dirty="0"/>
-          </a:p>
-        </p:txBody>
-      </p:sp>
-      <p:sp>
-        <p:nvSpPr>
-          <p:cNvPr id="11" name="Text 8"/>
-          <p:cNvSpPr/>
-          <p:nvPr/>
-        </p:nvSpPr>
-        <p:spPr>
-          <a:xfrm>
-            <a:off x="6172200" y="1078992"/>
-            <a:ext cx="960120" cy="201168"/>
-          </a:xfrm>
-          <a:prstGeom prst="rect">
-            <a:avLst/>
-          </a:prstGeom>
-          <a:noFill/>
-          <a:ln/>
-        </p:spPr>
-        <p:txBody>
-          <a:bodyPr wrap="square" lIns="0" tIns="0" rIns="0" bIns="0" rtlCol="0" anchor="ctr"/>
-          <a:lstStyle/>
-          <a:p>
-            <a:pPr algn="ctr" indent="0" marL="0">
-              <a:buNone/>
-            </a:pPr>
-            <a:r>
-              <a:rPr lang="en-US" sz="800" b="1" spc="100" kern="0" dirty="0">
-                <a:solidFill>
-                  <a:srgbClr val="FFFFFF"/>
-                </a:solidFill>
-                <a:latin typeface="Plus Jakarta Sans" pitchFamily="34" charset="0"/>
-                <a:ea typeface="Plus Jakarta Sans" pitchFamily="34" charset="-122"/>
-                <a:cs typeface="Plus Jakarta Sans" pitchFamily="34" charset="-120"/>
-              </a:rPr>
-              <a:t>NO SHOW</a:t>
-            </a:r>
-            <a:endParaRPr lang="en-US" sz="800" dirty="0"/>
-          </a:p>
-        </p:txBody>
-      </p:sp>
-      <p:sp>
-        <p:nvSpPr>
-          <p:cNvPr id="17" name="Text 14"/>
-          <p:cNvSpPr/>
-          <p:nvPr/>
-        </p:nvSpPr>
-        <p:spPr>
-          <a:xfrm>
-            <a:off x="6172200" y="1499616"/>
-            <a:ext cx="960120" cy="201168"/>
-          </a:xfrm>
-          <a:prstGeom prst="rect">
-            <a:avLst/>
-          </a:prstGeom>
-          <a:noFill/>
-          <a:ln/>
-        </p:spPr>
-        <p:txBody>
-          <a:bodyPr wrap="square" lIns="0" tIns="0" rIns="0" bIns="0" rtlCol="0" anchor="ctr"/>
-          <a:lstStyle/>
-          <a:p>
-            <a:pPr algn="ctr" indent="0" marL="0">
-              <a:buNone/>
-            </a:pPr>
-            <a:r>
-              <a:rPr lang="en-US" sz="1000" dirty="0">
-                <a:solidFill>
-                  <a:srgbClr val="5A5470"/>
-                </a:solidFill>
-                <a:latin typeface="Times New Roman" pitchFamily="34" charset="0"/>
-                <a:ea typeface="Times New Roman" pitchFamily="34" charset="-122"/>
-                <a:cs typeface="Times New Roman" pitchFamily="34" charset="-120"/>
-              </a:rPr>
-              <a:t>—</a:t>
-            </a:r>
-            <a:endParaRPr lang="en-US" sz="1000" dirty="0"/>
-          </a:p>
-        </p:txBody>
-      </p:sp>
-      <p:sp>
-        <p:nvSpPr>
-          <p:cNvPr id="22" name="Text 19"/>
-          <p:cNvSpPr/>
-          <p:nvPr/>
-        </p:nvSpPr>
-        <p:spPr>
-          <a:xfrm>
-            <a:off x="6172200" y="1700784"/>
-            <a:ext cx="960120" cy="201168"/>
-          </a:xfrm>
-          <a:prstGeom prst="rect">
-            <a:avLst/>
-          </a:prstGeom>
-          <a:noFill/>
-          <a:ln/>
-        </p:spPr>
-        <p:txBody>
-          <a:bodyPr wrap="square" lIns="0" tIns="0" rIns="0" bIns="0" rtlCol="0" anchor="ctr"/>
-          <a:lstStyle/>
-          <a:p>
-            <a:pPr algn="ctr" indent="0" marL="0">
-              <a:buNone/>
-            </a:pPr>
-            <a:r>
-              <a:rPr lang="en-US" sz="1000" dirty="0">
-                <a:solidFill>
-                  <a:srgbClr val="5A5470"/>
-                </a:solidFill>
-                <a:latin typeface="Times New Roman" pitchFamily="34" charset="0"/>
-                <a:ea typeface="Times New Roman" pitchFamily="34" charset="-122"/>
-                <a:cs typeface="Times New Roman" pitchFamily="34" charset="-120"/>
-              </a:rPr>
-              <a:t>—</a:t>
-            </a:r>
-            <a:endParaRPr lang="en-US" sz="1000" dirty="0"/>
-          </a:p>
-        </p:txBody>
-      </p:sp>
-      <p:sp>
-        <p:nvSpPr>
-          <p:cNvPr id="26" name="Text 23"/>
-          <p:cNvSpPr/>
-          <p:nvPr/>
-        </p:nvSpPr>
-        <p:spPr>
-          <a:xfrm>
-            <a:off x="6172200" y="1901952"/>
-            <a:ext cx="960120" cy="201168"/>
-          </a:xfrm>
-          <a:prstGeom prst="rect">
-            <a:avLst/>
-          </a:prstGeom>
-          <a:noFill/>
-          <a:ln/>
-        </p:spPr>
-        <p:txBody>
-          <a:bodyPr wrap="square" lIns="0" tIns="0" rIns="0" bIns="0" rtlCol="0" anchor="ctr"/>
-          <a:lstStyle/>
-          <a:p>
-            <a:pPr algn="ctr" indent="0" marL="0">
-              <a:buNone/>
-            </a:pPr>
-            <a:r>
-              <a:rPr lang="en-US" sz="1000" dirty="0">
-                <a:solidFill>
-                  <a:srgbClr val="5A5470"/>
-                </a:solidFill>
-                <a:latin typeface="Times New Roman" pitchFamily="34" charset="0"/>
-                <a:ea typeface="Times New Roman" pitchFamily="34" charset="-122"/>
-                <a:cs typeface="Times New Roman" pitchFamily="34" charset="-120"/>
-              </a:rPr>
-              <a:t>—</a:t>
-            </a:r>
-            <a:endParaRPr lang="en-US" sz="1000" dirty="0"/>
-          </a:p>
-        </p:txBody>
-      </p:sp>
-      <p:sp>
-        <p:nvSpPr>
-          <p:cNvPr id="31" name="Text 28"/>
-          <p:cNvSpPr/>
-          <p:nvPr/>
-        </p:nvSpPr>
-        <p:spPr>
-          <a:xfrm>
-            <a:off x="6172200" y="2103120"/>
-            <a:ext cx="960120" cy="201168"/>
-          </a:xfrm>
-          <a:prstGeom prst="rect">
-            <a:avLst/>
-          </a:prstGeom>
-          <a:noFill/>
-          <a:ln/>
-        </p:spPr>
-        <p:txBody>
-          <a:bodyPr wrap="square" lIns="0" tIns="0" rIns="0" bIns="0" rtlCol="0" anchor="ctr"/>
-          <a:lstStyle/>
-          <a:p>
-            <a:pPr algn="ctr" indent="0" marL="0">
-              <a:buNone/>
-            </a:pPr>
-            <a:r>
-              <a:rPr lang="en-US" sz="1000" dirty="0">
-                <a:solidFill>
-                  <a:srgbClr val="5A5470"/>
-                </a:solidFill>
-                <a:latin typeface="Times New Roman" pitchFamily="34" charset="0"/>
-                <a:ea typeface="Times New Roman" pitchFamily="34" charset="-122"/>
-                <a:cs typeface="Times New Roman" pitchFamily="34" charset="-120"/>
-              </a:rPr>
-              <a:t>—</a:t>
-            </a:r>
-            <a:endParaRPr lang="en-US" sz="1000" dirty="0"/>
-          </a:p>
-        </p:txBody>
-      </p:sp>
-      <p:sp>
-        <p:nvSpPr>
-          <p:cNvPr id="35" name="Text 32"/>
-          <p:cNvSpPr/>
-          <p:nvPr/>
-        </p:nvSpPr>
-        <p:spPr>
-          <a:xfrm>
-            <a:off x="6172200" y="2304288"/>
-            <a:ext cx="960120" cy="201168"/>
-          </a:xfrm>
-          <a:prstGeom prst="rect">
-            <a:avLst/>
-          </a:prstGeom>
-          <a:noFill/>
-          <a:ln/>
-        </p:spPr>
-        <p:txBody>
-          <a:bodyPr wrap="square" lIns="0" tIns="0" rIns="0" bIns="0" rtlCol="0" anchor="ctr"/>
-          <a:lstStyle/>
-          <a:p>
-            <a:pPr algn="ctr" indent="0" marL="0">
-              <a:buNone/>
-            </a:pPr>
-            <a:r>
-              <a:rPr lang="en-US" sz="1000" dirty="0">
-                <a:solidFill>
-                  <a:srgbClr val="5A5470"/>
-                </a:solidFill>
-                <a:latin typeface="Times New Roman" pitchFamily="34" charset="0"/>
-                <a:ea typeface="Times New Roman" pitchFamily="34" charset="-122"/>
-                <a:cs typeface="Times New Roman" pitchFamily="34" charset="-120"/>
-              </a:rPr>
-              <a:t>—</a:t>
-            </a:r>
-            <a:endParaRPr lang="en-US" sz="1000" dirty="0"/>
-          </a:p>
-        </p:txBody>
-      </p:sp>
-      <p:sp>
-        <p:nvSpPr>
-          <p:cNvPr id="40" name="Text 37"/>
-          <p:cNvSpPr/>
-          <p:nvPr/>
-        </p:nvSpPr>
-        <p:spPr>
-          <a:xfrm>
-            <a:off x="6172200" y="2505456"/>
-            <a:ext cx="960120" cy="201168"/>
-          </a:xfrm>
-          <a:prstGeom prst="rect">
-            <a:avLst/>
-          </a:prstGeom>
-          <a:noFill/>
-          <a:ln/>
-        </p:spPr>
-        <p:txBody>
-          <a:bodyPr wrap="square" lIns="0" tIns="0" rIns="0" bIns="0" rtlCol="0" anchor="ctr"/>
-          <a:lstStyle/>
-          <a:p>
-            <a:pPr algn="ctr" indent="0" marL="0">
-              <a:buNone/>
-            </a:pPr>
-            <a:r>
-              <a:rPr lang="en-US" sz="1000" dirty="0">
-                <a:solidFill>
-                  <a:srgbClr val="5A5470"/>
-                </a:solidFill>
-                <a:latin typeface="Times New Roman" pitchFamily="34" charset="0"/>
-                <a:ea typeface="Times New Roman" pitchFamily="34" charset="-122"/>
-                <a:cs typeface="Times New Roman" pitchFamily="34" charset="-120"/>
-              </a:rPr>
-              <a:t>—</a:t>
-            </a:r>
-            <a:endParaRPr lang="en-US" sz="1000" dirty="0"/>
-          </a:p>
-        </p:txBody>
-      </p:sp>
-      <p:sp>
-        <p:nvSpPr>
-          <p:cNvPr id="44" name="Text 41"/>
-          <p:cNvSpPr/>
-          <p:nvPr/>
-        </p:nvSpPr>
-        <p:spPr>
-          <a:xfrm>
-            <a:off x="6172200" y="2706624"/>
-            <a:ext cx="960120" cy="201168"/>
-          </a:xfrm>
-          <a:prstGeom prst="rect">
-            <a:avLst/>
-          </a:prstGeom>
-          <a:noFill/>
-          <a:ln/>
-        </p:spPr>
-        <p:txBody>
-          <a:bodyPr wrap="square" lIns="0" tIns="0" rIns="0" bIns="0" rtlCol="0" anchor="ctr"/>
-          <a:lstStyle/>
-          <a:p>
-            <a:pPr algn="ctr" indent="0" marL="0">
-              <a:buNone/>
-            </a:pPr>
-            <a:r>
-              <a:rPr lang="en-US" sz="1000" dirty="0">
-                <a:solidFill>
-                  <a:srgbClr val="5A5470"/>
-                </a:solidFill>
-                <a:latin typeface="Times New Roman" pitchFamily="34" charset="0"/>
-                <a:ea typeface="Times New Roman" pitchFamily="34" charset="-122"/>
-                <a:cs typeface="Times New Roman" pitchFamily="34" charset="-120"/>
-              </a:rPr>
-              <a:t>—</a:t>
-            </a:r>
-            <a:endParaRPr lang="en-US" sz="1000" dirty="0"/>
-          </a:p>
-        </p:txBody>
-      </p:sp>
-      <p:sp>
-        <p:nvSpPr>
-          <p:cNvPr id="51" name="Text 48"/>
-          <p:cNvSpPr/>
-          <p:nvPr/>
-        </p:nvSpPr>
-        <p:spPr>
-          <a:xfrm>
-            <a:off x="6172200" y="3108960"/>
-            <a:ext cx="960120" cy="201168"/>
-          </a:xfrm>
-          <a:prstGeom prst="rect">
-            <a:avLst/>
-          </a:prstGeom>
-          <a:noFill/>
-          <a:ln/>
-        </p:spPr>
-        <p:txBody>
-          <a:bodyPr wrap="square" lIns="0" tIns="0" rIns="0" bIns="0" rtlCol="0" anchor="ctr"/>
-          <a:lstStyle/>
-          <a:p>
-            <a:pPr algn="ctr" indent="0" marL="0">
-              <a:buNone/>
-            </a:pPr>
-            <a:r>
-              <a:rPr lang="en-US" sz="1000" dirty="0">
-                <a:solidFill>
-                  <a:srgbClr val="5A5470"/>
-                </a:solidFill>
-                <a:latin typeface="Times New Roman" pitchFamily="34" charset="0"/>
-                <a:ea typeface="Times New Roman" pitchFamily="34" charset="-122"/>
-                <a:cs typeface="Times New Roman" pitchFamily="34" charset="-120"/>
-              </a:rPr>
-              <a:t>—</a:t>
-            </a:r>
-            <a:endParaRPr lang="en-US" sz="1000" dirty="0"/>
-          </a:p>
-        </p:txBody>
-      </p:sp>
-      <p:sp>
-        <p:nvSpPr>
-          <p:cNvPr id="56" name="Text 53"/>
-          <p:cNvSpPr/>
-          <p:nvPr/>
-        </p:nvSpPr>
-        <p:spPr>
-          <a:xfrm>
-            <a:off x="6172200" y="3310128"/>
-            <a:ext cx="960120" cy="201168"/>
-          </a:xfrm>
-          <a:prstGeom prst="rect">
-            <a:avLst/>
-          </a:prstGeom>
-          <a:noFill/>
-          <a:ln/>
-        </p:spPr>
-        <p:txBody>
-          <a:bodyPr wrap="square" lIns="0" tIns="0" rIns="0" bIns="0" rtlCol="0" anchor="ctr"/>
-          <a:lstStyle/>
-          <a:p>
-            <a:pPr algn="ctr" indent="0" marL="0">
-              <a:buNone/>
-            </a:pPr>
-            <a:r>
-              <a:rPr lang="en-US" sz="1000" dirty="0">
-                <a:solidFill>
-                  <a:srgbClr val="5A5470"/>
-                </a:solidFill>
-                <a:latin typeface="Times New Roman" pitchFamily="34" charset="0"/>
-                <a:ea typeface="Times New Roman" pitchFamily="34" charset="-122"/>
-                <a:cs typeface="Times New Roman" pitchFamily="34" charset="-120"/>
-              </a:rPr>
-              <a:t>—</a:t>
-            </a:r>
-            <a:endParaRPr lang="en-US" sz="1000" dirty="0"/>
-          </a:p>
-        </p:txBody>
-      </p:sp>
-      <p:sp>
-        <p:nvSpPr>
-          <p:cNvPr id="60" name="Text 57"/>
-          <p:cNvSpPr/>
-          <p:nvPr/>
-        </p:nvSpPr>
-        <p:spPr>
-          <a:xfrm>
-            <a:off x="6172200" y="3511296"/>
-            <a:ext cx="960120" cy="201168"/>
-          </a:xfrm>
-          <a:prstGeom prst="rect">
-            <a:avLst/>
-          </a:prstGeom>
-          <a:noFill/>
-          <a:ln/>
-        </p:spPr>
-        <p:txBody>
-          <a:bodyPr wrap="square" lIns="0" tIns="0" rIns="0" bIns="0" rtlCol="0" anchor="ctr"/>
-          <a:lstStyle/>
-          <a:p>
-            <a:pPr algn="ctr" indent="0" marL="0">
-              <a:buNone/>
-            </a:pPr>
-            <a:r>
-              <a:rPr lang="en-US" sz="1000" dirty="0">
-                <a:solidFill>
-                  <a:srgbClr val="5A5470"/>
-                </a:solidFill>
-                <a:latin typeface="Times New Roman" pitchFamily="34" charset="0"/>
-                <a:ea typeface="Times New Roman" pitchFamily="34" charset="-122"/>
-                <a:cs typeface="Times New Roman" pitchFamily="34" charset="-120"/>
-              </a:rPr>
-              <a:t>—</a:t>
-            </a:r>
-            <a:endParaRPr lang="en-US" sz="1000" dirty="0"/>
-          </a:p>
-        </p:txBody>
-      </p:sp>
-      <p:sp>
-        <p:nvSpPr>
-          <p:cNvPr id="65" name="Text 62"/>
-          <p:cNvSpPr/>
-          <p:nvPr/>
-        </p:nvSpPr>
-        <p:spPr>
-          <a:xfrm>
-            <a:off x="6172200" y="3712464"/>
-            <a:ext cx="960120" cy="201168"/>
-          </a:xfrm>
-          <a:prstGeom prst="rect">
-            <a:avLst/>
-          </a:prstGeom>
-          <a:noFill/>
-          <a:ln/>
-        </p:spPr>
-        <p:txBody>
-          <a:bodyPr wrap="square" lIns="0" tIns="0" rIns="0" bIns="0" rtlCol="0" anchor="ctr"/>
-          <a:lstStyle/>
-          <a:p>
-            <a:pPr algn="ctr" indent="0" marL="0">
-              <a:buNone/>
-            </a:pPr>
-            <a:r>
-              <a:rPr lang="en-US" sz="1000" dirty="0">
-                <a:solidFill>
-                  <a:srgbClr val="5A5470"/>
-                </a:solidFill>
-                <a:latin typeface="Times New Roman" pitchFamily="34" charset="0"/>
-                <a:ea typeface="Times New Roman" pitchFamily="34" charset="-122"/>
-                <a:cs typeface="Times New Roman" pitchFamily="34" charset="-120"/>
-              </a:rPr>
-              <a:t>—</a:t>
-            </a:r>
-            <a:endParaRPr lang="en-US" sz="1000" dirty="0"/>
-          </a:p>
-        </p:txBody>
-      </p:sp>
-      <p:sp>
-        <p:nvSpPr>
-          <p:cNvPr id="69" name="Text 66"/>
-          <p:cNvSpPr/>
-          <p:nvPr/>
-        </p:nvSpPr>
-        <p:spPr>
-          <a:xfrm>
-            <a:off x="6172200" y="3913632"/>
-            <a:ext cx="960120" cy="201168"/>
-          </a:xfrm>
-          <a:prstGeom prst="rect">
-            <a:avLst/>
-          </a:prstGeom>
-          <a:noFill/>
-          <a:ln/>
-        </p:spPr>
-        <p:txBody>
-          <a:bodyPr wrap="square" lIns="0" tIns="0" rIns="0" bIns="0" rtlCol="0" anchor="ctr"/>
-          <a:lstStyle/>
-          <a:p>
-            <a:pPr algn="ctr" indent="0" marL="0">
-              <a:buNone/>
-            </a:pPr>
-            <a:r>
-              <a:rPr lang="en-US" sz="1000" dirty="0">
-                <a:solidFill>
-                  <a:srgbClr val="5A5470"/>
-                </a:solidFill>
-                <a:latin typeface="Times New Roman" pitchFamily="34" charset="0"/>
-                <a:ea typeface="Times New Roman" pitchFamily="34" charset="-122"/>
-                <a:cs typeface="Times New Roman" pitchFamily="34" charset="-120"/>
-              </a:rPr>
-              <a:t>—</a:t>
-            </a:r>
-            <a:endParaRPr lang="en-US" sz="1000" dirty="0"/>
-          </a:p>
-        </p:txBody>
-      </p:sp>
-      <p:sp>
-        <p:nvSpPr>
-          <p:cNvPr id="74" name="Text 71"/>
-          <p:cNvSpPr/>
-          <p:nvPr/>
-        </p:nvSpPr>
-        <p:spPr>
-          <a:xfrm>
-            <a:off x="6172200" y="4114800"/>
-            <a:ext cx="960120" cy="201168"/>
-          </a:xfrm>
-          <a:prstGeom prst="rect">
-            <a:avLst/>
-          </a:prstGeom>
-          <a:noFill/>
-          <a:ln/>
-        </p:spPr>
-        <p:txBody>
-          <a:bodyPr wrap="square" lIns="0" tIns="0" rIns="0" bIns="0" rtlCol="0" anchor="ctr"/>
-          <a:lstStyle/>
-          <a:p>
-            <a:pPr algn="ctr" indent="0" marL="0">
-              <a:buNone/>
-            </a:pPr>
-            <a:r>
-              <a:rPr lang="en-US" sz="1000" dirty="0">
-                <a:solidFill>
-                  <a:srgbClr val="5A5470"/>
-                </a:solidFill>
-                <a:latin typeface="Times New Roman" pitchFamily="34" charset="0"/>
-                <a:ea typeface="Times New Roman" pitchFamily="34" charset="-122"/>
-                <a:cs typeface="Times New Roman" pitchFamily="34" charset="-120"/>
-              </a:rPr>
-              <a:t>—</a:t>
-            </a:r>
-            <a:endParaRPr lang="en-US" sz="1000" dirty="0"/>
-          </a:p>
-        </p:txBody>
-      </p:sp>
-      <p:sp>
-        <p:nvSpPr>
-          <p:cNvPr id="78" name="Text 75"/>
-          <p:cNvSpPr/>
-          <p:nvPr/>
-        </p:nvSpPr>
-        <p:spPr>
-          <a:xfrm>
-            <a:off x="6172200" y="4315968"/>
-            <a:ext cx="960120" cy="201168"/>
-          </a:xfrm>
-          <a:prstGeom prst="rect">
-            <a:avLst/>
-          </a:prstGeom>
-          <a:noFill/>
-          <a:ln/>
-        </p:spPr>
-        <p:txBody>
-          <a:bodyPr wrap="square" lIns="0" tIns="0" rIns="0" bIns="0" rtlCol="0" anchor="ctr"/>
-          <a:lstStyle/>
-          <a:p>
-            <a:pPr algn="ctr" indent="0" marL="0">
-              <a:buNone/>
-            </a:pPr>
-            <a:r>
-              <a:rPr lang="en-US" sz="1000" dirty="0">
-                <a:solidFill>
-                  <a:srgbClr val="5A5470"/>
-                </a:solidFill>
-                <a:latin typeface="Times New Roman" pitchFamily="34" charset="0"/>
-                <a:ea typeface="Times New Roman" pitchFamily="34" charset="-122"/>
-                <a:cs typeface="Times New Roman" pitchFamily="34" charset="-120"/>
-              </a:rPr>
-              <a:t>—</a:t>
-            </a:r>
-            <a:endParaRPr lang="en-US" sz="1000" dirty="0"/>
           </a:p>
         </p:txBody>
       </p:sp>

</xml_diff>